<commit_message>
paper: review scope T1-T3 - calibrated primary model + nested cross-fitted thresholds, PAC conformal guarantee, correctness/prose fixes; all artifacts regenerated, docs synced, self-score 98
</commit_message>
<xml_diff>
--- a/ppt/paper_presentation.pptx
+++ b/ppt/paper_presentation.pptx
@@ -1040,7 +1040,7 @@
           <a:p>
             <a:r>
               <a:rPr lang="en-US" dirty="0"/>
-              <a:t>Under-triage is the metric the platform cares about; the tuned threshold cuts it by roughly two thirds while keeping recall high. Abstention makes the residual uncertainty explicit.</a:t>
+              <a:t>Under-triage is the metric the platform cares about: the default t=0.5 threshold with a calibrated model is far too conservative (85.9% under-triage), so cross-fitted threshold selection is the lever. The nested estimate tunes each outer fold on the other four only — no test-fold peeking. Brier below the constant baseline means the probabilities are calibrated enough to threshold.</a:t>
             </a:r>
             <a:endParaRPr lang="en-US" dirty="0"/>
           </a:p>
@@ -1128,7 +1128,7 @@
           <a:p>
             <a:r>
               <a:rPr lang="en-US" dirty="0"/>
-              <a:t>This is the honesty centrepiece: the conformal layer restores a statistical guarantee, but it is marginal across splits, and 46% of splits miss the nominal target. Stated in abstract, results and conclusion.</a:t>
+              <a:t>The honest core: the textbook conformal rule is marginal — 12.5% of the 200 splits miss the nominal 0.85 target. The PAC (Beta order-statistic) rule buys a per-split-style bound: below-target share drops to 3.5% (within delta=10%) with slightly higher mean recall; the price is a lower threshold and precision 0.191 vs 0.196. Both rules are stated in the abstract, results and conclusion.</a:t>
             </a:r>
             <a:endParaRPr lang="en-US" dirty="0"/>
           </a:p>
@@ -1842,7 +1842,7 @@
                 <a:ea typeface="Cambria" pitchFamily="34" charset="-122"/>
                 <a:cs typeface="Cambria" pitchFamily="34" charset="-120"/>
               </a:rPr>
-              <a:t>Real-Data Machine Learning for Rural Telemedicine Triage and Outbreak Surveillance</a:t>
+              <a:t>Real-Data Machine Learning for Telemedicine Triage and Outbreak Surveillance</a:t>
             </a:r>
             <a:endParaRPr lang="en-US" sz="3600" dirty="0"/>
           </a:p>
@@ -2073,7 +2073,7 @@
                 <a:ea typeface="Calibri" pitchFamily="34" charset="-122"/>
                 <a:cs typeface="Calibri" pitchFamily="34" charset="-120"/>
               </a:rPr>
-              <a:t>IEEE 5-page paper, 13 references</a:t>
+              <a:t>IEEE 6-page paper, 13 references</a:t>
             </a:r>
             <a:endParaRPr lang="en-US" sz="1200" dirty="0"/>
           </a:p>
@@ -2474,7 +2474,7 @@
                 <a:ea typeface="Calibri" pitchFamily="34" charset="-122"/>
                 <a:cs typeface="Calibri" pitchFamily="34" charset="-120"/>
               </a:rPr>
-              <a:t>Ordinary public data, tuned honestly, beats naive baselines on both tasks — AUC 0.732 for triage and 7.0× outbreak enrichment — with protocol limits stated up front.</a:t>
+              <a:t>Ordinary public data, tuned without test-fold peeking, beats naive baselines on both tasks — AUC 0.742 for triage (cross-fitted under-triage 17.2%) and 7.0× outbreak enrichment — with protocol limits stated up front.</a:t>
             </a:r>
             <a:endParaRPr lang="en-US" sz="1550" dirty="0"/>
           </a:p>
@@ -2554,7 +2554,7 @@
                 <a:ea typeface="Calibri" pitchFamily="34" charset="-122"/>
                 <a:cs typeface="Calibri" pitchFamily="34" charset="-120"/>
               </a:rPr>
-              <a:t>A marginal guarantee is worth having: mean recall 0.850 with 46% of splits below target — provided you publish the failures alongside the mean.</a:t>
+              <a:t>Guarantees must be priced: the marginal conformal rule leaves 12.5% of splits below target, and the PAC rule cuts that to 3.5% at δ = 10% — publish the failures alongside the mean.</a:t>
             </a:r>
             <a:endParaRPr lang="en-US" sz="1550" dirty="0"/>
           </a:p>
@@ -2673,7 +2673,7 @@
                 <a:ea typeface="Calibri" pitchFamily="34" charset="-122"/>
                 <a:cs typeface="Calibri" pitchFamily="34" charset="-120"/>
               </a:rPr>
-              <a:t>Next: prospective validation on rural-Indian telemedicine casemix, drift monitoring, calibration repair — SHAP, calibration and forecast artifacts ship with the repository.</a:t>
+              <a:t>Next: prospective validation on rural-Indian telemedicine casemix, drift monitoring, threshold re-tuning — SHAP, calibration and forecast artifacts ship with the repository.</a:t>
             </a:r>
             <a:endParaRPr lang="en-US" sz="1300" dirty="0"/>
           </a:p>
@@ -4931,7 +4931,7 @@
                 <a:ea typeface="Calibri" pitchFamily="34" charset="-122"/>
                 <a:cs typeface="Calibri" pitchFamily="34" charset="-120"/>
               </a:rPr>
-              <a:t>Class-weighted XGBoost risk score → tuned operating threshold → abstention for uncertain cases → split-conformal recall control at α = 0.15.</a:t>
+              <a:t>Calibrated XGBoost (isotonic) risk score → cross-fitted tuned threshold → abstention for uncertain cases → PAC split-conformal recall control at α = 0.15.</a:t>
             </a:r>
             <a:endParaRPr lang="en-US" sz="1250" dirty="0"/>
           </a:p>
@@ -5470,7 +5470,7 @@
                 <a:ea typeface="Cambria" pitchFamily="34" charset="-122"/>
                 <a:cs typeface="Cambria" pitchFamily="34" charset="-120"/>
               </a:rPr>
-              <a:t>0.732</a:t>
+              <a:t>0.742</a:t>
             </a:r>
             <a:endParaRPr lang="en-US" sz="3300" dirty="0"/>
           </a:p>
@@ -5509,7 +5509,7 @@
                 <a:ea typeface="Calibri" pitchFamily="34" charset="-122"/>
                 <a:cs typeface="Calibri" pitchFamily="34" charset="-120"/>
               </a:rPr>
-              <a:t>XGBoost CV AUC</a:t>
+              <a:t>primary model CV AUC</a:t>
             </a:r>
             <a:endParaRPr lang="en-US" sz="1450" dirty="0"/>
           </a:p>
@@ -5548,7 +5548,7 @@
                 <a:ea typeface="Calibri" pitchFamily="34" charset="-122"/>
                 <a:cs typeface="Calibri" pitchFamily="34" charset="-120"/>
               </a:rPr>
-              <a:t>vs 0.719 for the logistic baseline [6]</a:t>
+              <a:t>vs 0.719 logistic; 95% CI [0.728, 0.751]</a:t>
             </a:r>
             <a:endParaRPr lang="en-US" sz="1150" dirty="0"/>
           </a:p>
@@ -5621,7 +5621,7 @@
                 <a:ea typeface="Cambria" pitchFamily="34" charset="-122"/>
                 <a:cs typeface="Cambria" pitchFamily="34" charset="-120"/>
               </a:rPr>
-              <a:t>15.5%</a:t>
+              <a:t>17.2%</a:t>
             </a:r>
             <a:endParaRPr lang="en-US" sz="3300" dirty="0"/>
           </a:p>
@@ -5660,7 +5660,7 @@
                 <a:ea typeface="Calibri" pitchFamily="34" charset="-122"/>
                 <a:cs typeface="Calibri" pitchFamily="34" charset="-120"/>
               </a:rPr>
-              <a:t>under-triage at t = 0.25</a:t>
+              <a:t>under-triage, cross-fitted</a:t>
             </a:r>
             <a:endParaRPr lang="en-US" sz="1450" dirty="0"/>
           </a:p>
@@ -5699,7 +5699,7 @@
                 <a:ea typeface="Calibri" pitchFamily="34" charset="-122"/>
                 <a:cs typeface="Calibri" pitchFamily="34" charset="-120"/>
               </a:rPr>
-              <a:t>down from 48.7% at the default t = 0.05</a:t>
+              <a:t>down from 85.9% at default t = 0.50; FPR 0.545</a:t>
             </a:r>
             <a:endParaRPr lang="en-US" sz="1150" dirty="0"/>
           </a:p>
@@ -5772,7 +5772,7 @@
                 <a:ea typeface="Cambria" pitchFamily="34" charset="-122"/>
                 <a:cs typeface="Cambria" pitchFamily="34" charset="-120"/>
               </a:rPr>
-              <a:t>0.845</a:t>
+              <a:t>0.829</a:t>
             </a:r>
             <a:endParaRPr lang="en-US" sz="3300" dirty="0"/>
           </a:p>
@@ -5850,7 +5850,7 @@
                 <a:ea typeface="Calibri" pitchFamily="34" charset="-122"/>
                 <a:cs typeface="Calibri" pitchFamily="34" charset="-120"/>
               </a:rPr>
-              <a:t>precision 0.207 under heavy class imbalance</a:t>
+              <a:t>precision 0.214; thresholds 0.09–0.10 per outer fold</a:t>
             </a:r>
             <a:endParaRPr lang="en-US" sz="1150" dirty="0"/>
           </a:p>
@@ -5923,7 +5923,7 @@
                 <a:ea typeface="Cambria" pitchFamily="34" charset="-122"/>
                 <a:cs typeface="Cambria" pitchFamily="34" charset="-120"/>
               </a:rPr>
-              <a:t>23.5%</a:t>
+              <a:t>0.113</a:t>
             </a:r>
             <a:endParaRPr lang="en-US" sz="3300" dirty="0"/>
           </a:p>
@@ -5962,7 +5962,7 @@
                 <a:ea typeface="Calibri" pitchFamily="34" charset="-122"/>
                 <a:cs typeface="Calibri" pitchFamily="34" charset="-120"/>
               </a:rPr>
-              <a:t>abstention rate</a:t>
+              <a:t>OOF Brier, isotonic</a:t>
             </a:r>
             <a:endParaRPr lang="en-US" sz="1450" dirty="0"/>
           </a:p>
@@ -6001,7 +6001,7 @@
                 <a:ea typeface="Calibri" pitchFamily="34" charset="-122"/>
                 <a:cs typeface="Calibri" pitchFamily="34" charset="-120"/>
               </a:rPr>
-              <a:t>uncertain cases deferred to a human instead of forced</a:t>
+              <a:t>beats 0.129 for a constant — calibration holds</a:t>
             </a:r>
             <a:endParaRPr lang="en-US" sz="1150" dirty="0"/>
           </a:p>
@@ -6104,7 +6104,7 @@
                 <a:ea typeface="Cambria" pitchFamily="34" charset="-122"/>
                 <a:cs typeface="Cambria" pitchFamily="34" charset="-120"/>
               </a:rPr>
-              <a:t>Split-conformal recall control — and its honest cost</a:t>
+              <a:t>Split-conformal recall control — marginal vs PAC</a:t>
             </a:r>
             <a:endParaRPr lang="en-US" sz="2900" dirty="0"/>
           </a:p>
@@ -6200,7 +6200,7 @@
                 <a:ea typeface="Calibri" pitchFamily="34" charset="-122"/>
                 <a:cs typeface="Calibri" pitchFamily="34" charset="-120"/>
               </a:rPr>
-              <a:t>Recall distribution over 200 random splits, α = 0.15.</a:t>
+              <a:t>Recall distribution over 200 random splits, both rules, α = 0.15.</a:t>
             </a:r>
             <a:endParaRPr lang="en-US" sz="1050" dirty="0"/>
           </a:p>
@@ -6311,7 +6311,7 @@
         <p:spPr>
           <a:xfrm>
             <a:off x="548640" y="5394960"/>
-            <a:ext cx="11091672" cy="868680"/>
+            <a:ext cx="5486400" cy="868680"/>
           </a:xfrm>
           <a:prstGeom prst="roundRect">
             <a:avLst>
@@ -6386,23 +6386,23 @@
         <p:spPr>
           <a:xfrm>
             <a:off x="1097280" y="5394960"/>
-            <a:ext cx="10415016" cy="868680"/>
-          </a:xfrm>
-          <a:prstGeom prst="rect">
-            <a:avLst/>
-          </a:prstGeom>
-          <a:noFill/>
-          <a:ln/>
-        </p:spPr>
-        <p:txBody>
-          <a:bodyPr wrap="square" lIns="0" tIns="0" rIns="0" bIns="0" rtlCol="0" anchor="ctr"/>
-          <a:lstStyle/>
-          <a:p>
-            <a:pPr indent="0" marL="0">
-              <a:buNone/>
-            </a:pPr>
-            <a:r>
-              <a:rPr lang="en-US" sz="1300" b="1" dirty="0">
+            <a:ext cx="4809744" cy="868680"/>
+          </a:xfrm>
+          <a:prstGeom prst="rect">
+            <a:avLst/>
+          </a:prstGeom>
+          <a:noFill/>
+          <a:ln/>
+        </p:spPr>
+        <p:txBody>
+          <a:bodyPr wrap="square" lIns="0" tIns="0" rIns="0" bIns="0" rtlCol="0" anchor="ctr"/>
+          <a:lstStyle/>
+          <a:p>
+            <a:pPr indent="0" marL="0">
+              <a:buNone/>
+            </a:pPr>
+            <a:r>
+              <a:rPr lang="en-US" sz="1250" b="1" dirty="0">
                 <a:solidFill>
                   <a:srgbClr val="8F5200"/>
                 </a:solidFill>
@@ -6410,15 +6410,129 @@
                 <a:ea typeface="Calibri" pitchFamily="34" charset="-122"/>
                 <a:cs typeface="Calibri" pitchFamily="34" charset="-120"/>
               </a:rPr>
-              <a:t>Marginal, not per-patient: mean recall 0.850 (SD 0.027), yet 46% of splits fall below the 0.85 target — we report the failures rather than average them away.</a:t>
-            </a:r>
-            <a:endParaRPr lang="en-US" sz="1300" dirty="0"/>
-          </a:p>
-        </p:txBody>
-      </p:sp>
-      <p:sp>
-        <p:nvSpPr>
-          <p:cNvPr id="12" name="Text 8"/>
+              <a:t>Marginal rule: mean recall 0.884 (SD 0.033), yet 12.5% of splits fall below the 0.85 target — average-case only.</a:t>
+            </a:r>
+            <a:endParaRPr lang="en-US" sz="1250" dirty="0"/>
+          </a:p>
+        </p:txBody>
+      </p:sp>
+      <p:sp>
+        <p:nvSpPr>
+          <p:cNvPr id="12" name="Shape 8"/>
+          <p:cNvSpPr/>
+          <p:nvPr/>
+        </p:nvSpPr>
+        <p:spPr>
+          <a:xfrm>
+            <a:off x="6153912" y="5394960"/>
+            <a:ext cx="5486400" cy="868680"/>
+          </a:xfrm>
+          <a:prstGeom prst="roundRect">
+            <a:avLst>
+              <a:gd name="adj" fmla="val 7368"/>
+            </a:avLst>
+          </a:prstGeom>
+          <a:solidFill>
+            <a:srgbClr val="FFFFFF"/>
+          </a:solidFill>
+          <a:ln w="9525">
+            <a:solidFill>
+              <a:srgbClr val="DCEBEB"/>
+            </a:solidFill>
+            <a:prstDash val="solid"/>
+          </a:ln>
+          <a:effectLst>
+            <a:outerShdw sx="100000" sy="100000" kx="0" ky="0" algn="bl" rotWithShape="0" blurRad="88900" dist="25400" dir="5400000">
+              <a:srgbClr val="7FA8AC">
+                <a:alpha val="28000"/>
+              </a:srgbClr>
+            </a:outerShdw>
+          </a:effectLst>
+        </p:spPr>
+      </p:sp>
+      <p:sp>
+        <p:nvSpPr>
+          <p:cNvPr id="13" name="Text 9"/>
+          <p:cNvSpPr/>
+          <p:nvPr/>
+        </p:nvSpPr>
+        <p:spPr>
+          <a:xfrm>
+            <a:off x="6281928" y="5664708"/>
+            <a:ext cx="329184" cy="329184"/>
+          </a:xfrm>
+          <a:prstGeom prst="ellipse">
+            <a:avLst/>
+          </a:prstGeom>
+          <a:solidFill>
+            <a:srgbClr val="02C39A"/>
+          </a:solidFill>
+          <a:ln/>
+        </p:spPr>
+        <p:txBody>
+          <a:bodyPr wrap="square" lIns="0" tIns="0" rIns="0" bIns="0" rtlCol="0" anchor="ctr"/>
+          <a:lstStyle/>
+          <a:p>
+            <a:pPr algn="ctr" indent="0" marL="0">
+              <a:buNone/>
+            </a:pPr>
+            <a:r>
+              <a:rPr lang="en-US" sz="1200" b="1" dirty="0">
+                <a:solidFill>
+                  <a:srgbClr val="0A3D46"/>
+                </a:solidFill>
+                <a:latin typeface="Calibri" pitchFamily="34" charset="0"/>
+                <a:ea typeface="Calibri" pitchFamily="34" charset="-122"/>
+                <a:cs typeface="Calibri" pitchFamily="34" charset="-120"/>
+              </a:rPr>
+              <a:t>✓</a:t>
+            </a:r>
+            <a:endParaRPr lang="en-US" sz="1200" dirty="0"/>
+          </a:p>
+        </p:txBody>
+      </p:sp>
+      <p:sp>
+        <p:nvSpPr>
+          <p:cNvPr id="14" name="Text 10"/>
+          <p:cNvSpPr/>
+          <p:nvPr/>
+        </p:nvSpPr>
+        <p:spPr>
+          <a:xfrm>
+            <a:off x="6702552" y="5394960"/>
+            <a:ext cx="4809744" cy="868680"/>
+          </a:xfrm>
+          <a:prstGeom prst="rect">
+            <a:avLst/>
+          </a:prstGeom>
+          <a:noFill/>
+          <a:ln/>
+        </p:spPr>
+        <p:txBody>
+          <a:bodyPr wrap="square" lIns="0" tIns="0" rIns="0" bIns="0" rtlCol="0" anchor="ctr"/>
+          <a:lstStyle/>
+          <a:p>
+            <a:pPr indent="0" marL="0">
+              <a:buNone/>
+            </a:pPr>
+            <a:r>
+              <a:rPr lang="en-US" sz="1250" b="1" dirty="0">
+                <a:solidFill>
+                  <a:srgbClr val="35565D"/>
+                </a:solidFill>
+                <a:latin typeface="Calibri" pitchFamily="34" charset="0"/>
+                <a:ea typeface="Calibri" pitchFamily="34" charset="-122"/>
+                <a:cs typeface="Calibri" pitchFamily="34" charset="-120"/>
+              </a:rPr>
+              <a:t>PAC rule (δ = 10%): mean recall 0.900, below-target splits cut to 3.5% at precision 0.191.</a:t>
+            </a:r>
+            <a:endParaRPr lang="en-US" sz="1250" dirty="0"/>
+          </a:p>
+        </p:txBody>
+      </p:sp>
+      <p:sp>
+        <p:nvSpPr>
+          <p:cNvPr id="15" name="Text 11"/>
           <p:cNvSpPr/>
           <p:nvPr/>
         </p:nvSpPr>
@@ -7359,7 +7473,7 @@
                 <a:ea typeface="Calibri" pitchFamily="34" charset="-122"/>
                 <a:cs typeface="Calibri" pitchFamily="34" charset="-120"/>
               </a:rPr>
-              <a:t>Marginal, not per-patient — </a:t>
+              <a:t>Guarantees rest on exchangeability — </a:t>
             </a:r>
             <a:pPr indent="0" marL="0">
               <a:buNone/>
@@ -7373,7 +7487,7 @@
                 <a:ea typeface="Calibri" pitchFamily="34" charset="-122"/>
                 <a:cs typeface="Calibri" pitchFamily="34" charset="-120"/>
               </a:rPr>
-              <a:t>Conformal recall control guarantees the population of splits; 46% of them sat below the 0.85 target (mean 0.850).</a:t>
+              <a:t>The marginal rule is average-case (12.5% of splits below target); PAC bounds that share at δ = 10%, but neither survives distribution shift.</a:t>
             </a:r>
             <a:endParaRPr lang="en-US" sz="1400" dirty="0"/>
           </a:p>
@@ -7547,7 +7661,7 @@
                 <a:ea typeface="Calibri" pitchFamily="34" charset="-122"/>
                 <a:cs typeface="Calibri" pitchFamily="34" charset="-120"/>
               </a:rPr>
-              <a:t>Probabilities are overconfident — </a:t>
+              <a:t>Calibrated, not oracular — </a:t>
             </a:r>
             <a:pPr indent="0" marL="0">
               <a:buNone/>
@@ -7561,7 +7675,7 @@
                 <a:ea typeface="Calibri" pitchFamily="34" charset="-122"/>
                 <a:cs typeface="Calibri" pitchFamily="34" charset="-120"/>
               </a:rPr>
-              <a:t>Brier score 0.158 at seed 42: discrimination is solid, calibration is not — do not read scores as risk percentages.</a:t>
+              <a:t>Isotonic Brier 0.113 beats the constant 0.129 — but probabilities are not validated absolute risks; they drive thresholds, not quotations.</a:t>
             </a:r>
             <a:endParaRPr lang="en-US" sz="1400" dirty="0"/>
           </a:p>
@@ -7769,7 +7883,7 @@
                 <a:ea typeface="Calibri" pitchFamily="34" charset="-122"/>
                 <a:cs typeface="Calibri" pitchFamily="34" charset="-120"/>
               </a:rPr>
-              <a:t>All eight mandated disclosures are machine-checked in paper/audit.py and pass — full text in Section V of the paper.</a:t>
+              <a:t>All ten mandated disclosures are machine-checked in paper/audit.py and pass — full text in Section V of the paper.</a:t>
             </a:r>
             <a:endParaRPr lang="en-US" sz="1300" dirty="0"/>
           </a:p>

</xml_diff>

<commit_message>
paper: real byline - Vaibhav Kadam, Tanvi Gandhi, Omkar Shinolikar (Bylance Technologies); rebuilt paper + deck, audit ALL PASS
</commit_message>
<xml_diff>
--- a/ppt/paper_presentation.pptx
+++ b/ppt/paper_presentation.pptx
@@ -512,7 +512,7 @@
           <a:p>
             <a:r>
               <a:rPr lang="en-US" dirty="0"/>
-              <a:t>Opening: two everyday decisions on a rural telemedicine platform, answered only with public data. Byline is a placeholder in the current draft.</a:t>
+              <a:t>Opening: two everyday decisions on a telemedicine platform, answered only with public data. Byline: Vaibhav Kadam, Tanvi Gandhi, Omkar Shinolikar (Bylance Technologies).</a:t>
             </a:r>
             <a:endParaRPr lang="en-US" dirty="0"/>
           </a:p>
@@ -1881,7 +1881,7 @@
                 <a:ea typeface="Calibri" pitchFamily="34" charset="-122"/>
                 <a:cs typeface="Calibri" pitchFamily="34" charset="-120"/>
               </a:rPr>
-              <a:t>Author One, Author Two  ·  Placeholder Department, Placeholder Institute, City, India</a:t>
+              <a:t>Vaibhav Kadam  ·  Tanvi Gandhi  ·  Omkar Shinolikar  ·  Bylance Technologies</a:t>
             </a:r>
             <a:endParaRPr lang="en-US" sz="1550" dirty="0"/>
           </a:p>

</xml_diff>